<commit_message>
Replace wine dataset with online shoppers conversion project
</commit_message>
<xml_diff>
--- a/Executive_Summary-Team1.pptx
+++ b/Executive_Summary-Team1.pptx
@@ -3157,7 +3157,7 @@
               </a:defRPr>
             </a:pPr>
             <a:r>
-              <a:t>Predicting High Quality Wine From Physicochemical Measurements</a:t>
+              <a:t>Predicting Online Purchase Conversion From Session Behavior</a:t>
             </a:r>
           </a:p>
         </p:txBody>
@@ -3192,7 +3192,7 @@
               </a:defRPr>
             </a:pPr>
             <a:r>
-              <a:t>Goal: predict whether a red wine will receive a high sensory quality score.</a:t>
+              <a:t>Goal: predict whether an online shopping session will generate revenue.</a:t>
             </a:r>
           </a:p>
           <a:p>
@@ -3204,7 +3204,7 @@
               </a:defRPr>
             </a:pPr>
             <a:r>
-              <a:t>Dataset: UCI red wine quality data with 1,599 samples.</a:t>
+              <a:t>Dataset: UCI online shoppers data with 12,330 sessions.</a:t>
             </a:r>
           </a:p>
           <a:p>
@@ -3216,7 +3216,7 @@
               </a:defRPr>
             </a:pPr>
             <a:r>
-              <a:t>High quality wines are the minority class: 13.6% of rows.</a:t>
+              <a:t>Purchases are the minority class: 15.5% of rows.</a:t>
             </a:r>
           </a:p>
           <a:p>
@@ -3228,14 +3228,14 @@
               </a:defRPr>
             </a:pPr>
             <a:r>
-              <a:t>Business use: screen wines for extra review before using scarce tasting-panel time.</a:t>
+              <a:t>Business use: rank sessions for targeted marketing or on-site intervention.</a:t>
             </a:r>
           </a:p>
         </p:txBody>
       </p:sp>
       <p:pic>
         <p:nvPicPr>
-          <p:cNvPr id="5" name="Picture 4" descr="quality_distribution.png"/>
+          <p:cNvPr id="5" name="Picture 4" descr="purchase_distribution.png"/>
           <p:cNvPicPr>
             <a:picLocks noChangeAspect="1"/>
           </p:cNvPicPr>
@@ -3340,7 +3340,7 @@
               </a:defRPr>
             </a:pPr>
             <a:r>
-              <a:t>Predicting High Quality Wine From Physicochemical Measurements</a:t>
+              <a:t>Predicting Online Purchase Conversion From Session Behavior</a:t>
             </a:r>
           </a:p>
         </p:txBody>
@@ -3375,7 +3375,7 @@
               </a:defRPr>
             </a:pPr>
             <a:r>
-              <a:t>Created binary target: quality score 7 or higher equals High.</a:t>
+              <a:t>Created binary target from the Revenue field.</a:t>
             </a:r>
           </a:p>
           <a:p>
@@ -3411,7 +3411,7 @@
               </a:defRPr>
             </a:pPr>
             <a:r>
-              <a:t>Used 5-fold cross-validation for tuning and threshold selection.</a:t>
+              <a:t>Used cross-validation for tuning and threshold selection.</a:t>
             </a:r>
           </a:p>
         </p:txBody>
@@ -3523,7 +3523,7 @@
               </a:defRPr>
             </a:pPr>
             <a:r>
-              <a:t>Predicting High Quality Wine From Physicochemical Measurements</a:t>
+              <a:t>Predicting Online Purchase Conversion From Session Behavior</a:t>
             </a:r>
           </a:p>
         </p:txBody>
@@ -3570,7 +3570,7 @@
               </a:defRPr>
             </a:pPr>
             <a:r>
-              <a:t>Test ROC AUC: 0.927.</a:t>
+              <a:t>Test ROC AUC: 0.935.</a:t>
             </a:r>
           </a:p>
           <a:p>
@@ -3582,7 +3582,7 @@
               </a:defRPr>
             </a:pPr>
             <a:r>
-              <a:t>Test F1 score: 0.673.</a:t>
+              <a:t>Test F1 score: 0.716.</a:t>
             </a:r>
           </a:p>
           <a:p>
@@ -3594,7 +3594,7 @@
               </a:defRPr>
             </a:pPr>
             <a:r>
-              <a:t>Threshold selected to balance precision and sensitivity for high quality wines.</a:t>
+              <a:t>Threshold selected to balance precision and sensitivity for purchase sessions.</a:t>
             </a:r>
           </a:p>
         </p:txBody>
@@ -3652,7 +3652,7 @@
             </a:r>
             <a:br/>
             <a:r>
-              <a:t>0.927</a:t>
+              <a:t>0.935</a:t>
             </a:r>
           </a:p>
         </p:txBody>
@@ -3710,7 +3710,7 @@
             </a:r>
             <a:br/>
             <a:r>
-              <a:t>0.673</a:t>
+              <a:t>0.716</a:t>
             </a:r>
           </a:p>
         </p:txBody>
@@ -3768,7 +3768,7 @@
             </a:r>
             <a:br/>
             <a:r>
-              <a:t>0.894</a:t>
+              <a:t>0.909</a:t>
             </a:r>
           </a:p>
         </p:txBody>
@@ -3880,7 +3880,7 @@
               </a:defRPr>
             </a:pPr>
             <a:r>
-              <a:t>Predicting High Quality Wine From Physicochemical Measurements</a:t>
+              <a:t>Predicting Online Purchase Conversion From Session Behavior</a:t>
             </a:r>
           </a:p>
         </p:txBody>
@@ -3927,7 +3927,7 @@
               </a:defRPr>
             </a:pPr>
             <a:r>
-              <a:t>alcohol, volatile acidity, sulphates, density, citric acid.</a:t>
+              <a:t>PageValues, ExitRates, ProductRelated_Duration, Month, ProductRelated.</a:t>
             </a:r>
           </a:p>
           <a:p>
@@ -3939,7 +3939,7 @@
               </a:defRPr>
             </a:pPr>
             <a:r>
-              <a:t>These measurements are plausible quality signals, but they do not replace tasting.</a:t>
+              <a:t>These are predictive signals, not proof of causation.</a:t>
             </a:r>
           </a:p>
           <a:p>
@@ -3951,7 +3951,7 @@
               </a:defRPr>
             </a:pPr>
             <a:r>
-              <a:t>Model should be used as a prioritization layer.</a:t>
+              <a:t>Model scores should be used as a prioritization layer.</a:t>
             </a:r>
           </a:p>
         </p:txBody>
@@ -4063,7 +4063,7 @@
               </a:defRPr>
             </a:pPr>
             <a:r>
-              <a:t>Predicting High Quality Wine From Physicochemical Measurements</a:t>
+              <a:t>Predicting Online Purchase Conversion From Session Behavior</a:t>
             </a:r>
           </a:p>
         </p:txBody>
@@ -4098,7 +4098,7 @@
               </a:defRPr>
             </a:pPr>
             <a:r>
-              <a:t>Use model scores to rank wines for extra sensory review.</a:t>
+              <a:t>Use model scores to rank sessions for controlled marketing experiments.</a:t>
             </a:r>
           </a:p>
           <a:p>
@@ -4110,7 +4110,7 @@
               </a:defRPr>
             </a:pPr>
             <a:r>
-              <a:t>Do not use the model as the only quality decision.</a:t>
+              <a:t>Do not assume an intervention creates incremental revenue without A/B testing.</a:t>
             </a:r>
           </a:p>
           <a:p>
@@ -4122,7 +4122,7 @@
               </a:defRPr>
             </a:pPr>
             <a:r>
-              <a:t>Improve with more wine types, producer information, vintage data, and external validation.</a:t>
+              <a:t>Improve with product, customer, pricing, margin, and campaign data.</a:t>
             </a:r>
           </a:p>
           <a:p>
@@ -4141,7 +4141,7 @@
       </p:sp>
       <p:pic>
         <p:nvPicPr>
-          <p:cNvPr id="5" name="Picture 4" descr="predictor_boxplots.png"/>
+          <p:cNvPr id="5" name="Picture 4" descr="session_behavior_boxplots.png"/>
           <p:cNvPicPr>
             <a:picLocks noChangeAspect="1"/>
           </p:cNvPicPr>

</xml_diff>